<commit_message>
Fill the official Business Model Canvas template with our content
Adds business-model-canvas-rempli.pdf: the exact BMC template PDF
provided for the assignment (Business Model Foundry / Neos Chronos,
CC BY-SA 3.0), filled in directly by writing text into the template's
own coordinate grid rather than recreating the layout from scratch --
guarantees pixel-perfect fidelity (same fonts, icons, borders).

Replaces the hand-built canvas-grid slide in both business-model-
canvas.pptx and business-model-canvas.html with a high-res render of
this filled template, so "the Canvas itself" (a distinct required
element of the assignment brief, separate from the per-rubric slides)
matches the exact template format expected.
</commit_message>
<xml_diff>
--- a/smart-city-platform/docs/business-model-canvas.pptx
+++ b/smart-city-platform/docs/business-model-canvas.pptx
@@ -5834,7 +5834,7 @@
     <p:bg>
       <p:bgPr>
         <a:solidFill>
-          <a:srgbClr val="0F172A"/>
+          <a:srgbClr val="FFFFFF"/>
         </a:solidFill>
         <a:effectLst/>
       </p:bgPr>
@@ -6012,52 +6012,30 @@
           </a:p>
         </p:txBody>
       </p:sp>
-      <p:sp>
-        <p:nvSpPr>
-          <p:cNvPr id="6" name="Rectangle 5"/>
-          <p:cNvSpPr/>
-          <p:nvPr/>
-        </p:nvSpPr>
-        <p:spPr>
-          <a:xfrm>
-            <a:off x="457200" y="1508760"/>
-            <a:ext cx="2258568" cy="4892040"/>
-          </a:xfrm>
-          <a:prstGeom prst="rect">
-            <a:avLst/>
-          </a:prstGeom>
-          <a:solidFill>
-            <a:srgbClr val="1E293B"/>
-          </a:solidFill>
-          <a:ln w="9525">
-            <a:solidFill>
-              <a:srgbClr val="334155"/>
-            </a:solidFill>
-          </a:ln>
-          <a:effectLst/>
-        </p:spPr>
-        <p:style>
-          <a:lnRef idx="1">
-            <a:schemeClr val="accent1"/>
-          </a:lnRef>
-          <a:fillRef idx="3">
-            <a:schemeClr val="accent1"/>
-          </a:fillRef>
-          <a:effectRef idx="2">
-            <a:schemeClr val="accent1"/>
-          </a:effectRef>
-          <a:fontRef idx="minor">
-            <a:schemeClr val="lt1"/>
-          </a:fontRef>
-        </p:style>
-        <p:txBody>
-          <a:bodyPr rtlCol="0" anchor="ctr"/>
-          <a:lstStyle/>
-          <a:p>
-            <a:pPr algn="ctr"/>
-          </a:p>
-        </p:txBody>
-      </p:sp>
+      <p:pic>
+        <p:nvPicPr>
+          <p:cNvPr id="6" name="Picture 5" descr="bmc_official.png"/>
+          <p:cNvPicPr>
+            <a:picLocks noChangeAspect="1"/>
+          </p:cNvPicPr>
+          <p:nvPr/>
+        </p:nvPicPr>
+        <p:blipFill>
+          <a:blip r:embed="rId2"/>
+          <a:stretch>
+            <a:fillRect/>
+          </a:stretch>
+        </p:blipFill>
+        <p:spPr>
+          <a:xfrm>
+            <a:off x="2463647" y="1417320"/>
+            <a:ext cx="7264400" cy="5029200"/>
+          </a:xfrm>
+          <a:prstGeom prst="rect">
+            <a:avLst/>
+          </a:prstGeom>
+        </p:spPr>
+      </p:pic>
       <p:sp>
         <p:nvSpPr>
           <p:cNvPr id="7" name="TextBox 6"/>
@@ -6066,8 +6044,8 @@
         </p:nvSpPr>
         <p:spPr>
           <a:xfrm>
-            <a:off x="530352" y="1554480"/>
-            <a:ext cx="2112264" cy="457200"/>
+            <a:off x="640080" y="6510528"/>
+            <a:ext cx="7315200" cy="274320"/>
           </a:xfrm>
           <a:prstGeom prst="rect">
             <a:avLst/>
@@ -6082,33 +6060,17 @@
           <a:p>
             <a:pPr algn="l">
               <a:lnSpc>
-                <a:spcPct val="95000"/>
-              </a:lnSpc>
-            </a:pPr>
-            <a:r>
-              <a:rPr sz="1150" b="1" i="0">
-                <a:solidFill>
-                  <a:srgbClr val="38BDF8"/>
-                </a:solidFill>
-                <a:latin typeface="Calibri"/>
-              </a:rPr>
-              <a:t>Partenaires</a:t>
-            </a:r>
-          </a:p>
-          <a:p>
-            <a:pPr algn="l">
-              <a:lnSpc>
-                <a:spcPct val="95000"/>
-              </a:lnSpc>
-            </a:pPr>
-            <a:r>
-              <a:rPr sz="1150" b="1" i="0">
-                <a:solidFill>
-                  <a:srgbClr val="38BDF8"/>
-                </a:solidFill>
-                <a:latin typeface="Calibri"/>
-              </a:rPr>
-              <a:t>clés</a:t>
+                <a:spcPct val="100000"/>
+              </a:lnSpc>
+            </a:pPr>
+            <a:r>
+              <a:rPr sz="1000" b="0" i="0">
+                <a:solidFill>
+                  <a:srgbClr val="64748B"/>
+                </a:solidFill>
+                <a:latin typeface="Calibri"/>
+              </a:rPr>
+              <a:t>Business Model Canvas — Smart City Lighting Platform</a:t>
             </a:r>
           </a:p>
         </p:txBody>
@@ -6121,8 +6083,8 @@
         </p:nvSpPr>
         <p:spPr>
           <a:xfrm>
-            <a:off x="530352" y="2194560"/>
-            <a:ext cx="2112264" cy="4251960"/>
+            <a:off x="11247120" y="6510528"/>
+            <a:ext cx="548640" cy="274320"/>
           </a:xfrm>
           <a:prstGeom prst="rect">
             <a:avLst/>
@@ -6135,1451 +6097,15 @@
           </a:bodyPr>
           <a:lstStyle/>
           <a:p>
-            <a:pPr algn="l">
-              <a:lnSpc>
-                <a:spcPct val="115000"/>
-              </a:lnSpc>
-            </a:pPr>
-            <a:r>
-              <a:rPr sz="950" b="0" i="0">
-                <a:solidFill>
-                  <a:srgbClr val="E2E8F0"/>
-                </a:solidFill>
-                <a:latin typeface="Calibri"/>
-              </a:rPr>
-              <a:t>Fabricants IoT</a:t>
-            </a:r>
-          </a:p>
-          <a:p>
-            <a:pPr algn="l">
-              <a:lnSpc>
-                <a:spcPct val="115000"/>
-              </a:lnSpc>
-            </a:pPr>
-            <a:r>
-              <a:rPr sz="950" b="0" i="0">
-                <a:solidFill>
-                  <a:srgbClr val="E2E8F0"/>
-                </a:solidFill>
-                <a:latin typeface="Calibri"/>
-              </a:rPr>
-              <a:t>Installateurs locaux</a:t>
-            </a:r>
-          </a:p>
-          <a:p>
-            <a:pPr algn="l">
-              <a:lnSpc>
-                <a:spcPct val="115000"/>
-              </a:lnSpc>
-            </a:pPr>
-            <a:r>
-              <a:rPr sz="950" b="0" i="0">
-                <a:solidFill>
-                  <a:srgbClr val="E2E8F0"/>
-                </a:solidFill>
-                <a:latin typeface="Calibri"/>
-              </a:rPr>
-              <a:t>Hébergeurs cloud</a:t>
-            </a:r>
-          </a:p>
-          <a:p>
-            <a:pPr algn="l">
-              <a:lnSpc>
-                <a:spcPct val="115000"/>
-              </a:lnSpc>
-            </a:pPr>
-            <a:r>
-              <a:rPr sz="950" b="0" i="0">
-                <a:solidFill>
-                  <a:srgbClr val="E2E8F0"/>
-                </a:solidFill>
-                <a:latin typeface="Calibri"/>
-              </a:rPr>
-              <a:t>Institutions publiques</a:t>
-            </a:r>
-          </a:p>
-        </p:txBody>
-      </p:sp>
-      <p:sp>
-        <p:nvSpPr>
-          <p:cNvPr id="9" name="Rectangle 8"/>
-          <p:cNvSpPr/>
-          <p:nvPr/>
-        </p:nvSpPr>
-        <p:spPr>
-          <a:xfrm>
-            <a:off x="2715768" y="1508760"/>
-            <a:ext cx="2258568" cy="2446020"/>
-          </a:xfrm>
-          <a:prstGeom prst="rect">
-            <a:avLst/>
-          </a:prstGeom>
-          <a:solidFill>
-            <a:srgbClr val="1E293B"/>
-          </a:solidFill>
-          <a:ln w="9525">
-            <a:solidFill>
-              <a:srgbClr val="334155"/>
-            </a:solidFill>
-          </a:ln>
-          <a:effectLst/>
-        </p:spPr>
-        <p:style>
-          <a:lnRef idx="1">
-            <a:schemeClr val="accent1"/>
-          </a:lnRef>
-          <a:fillRef idx="3">
-            <a:schemeClr val="accent1"/>
-          </a:fillRef>
-          <a:effectRef idx="2">
-            <a:schemeClr val="accent1"/>
-          </a:effectRef>
-          <a:fontRef idx="minor">
-            <a:schemeClr val="lt1"/>
-          </a:fontRef>
-        </p:style>
-        <p:txBody>
-          <a:bodyPr rtlCol="0" anchor="ctr"/>
-          <a:lstStyle/>
-          <a:p>
-            <a:pPr algn="ctr"/>
-          </a:p>
-        </p:txBody>
-      </p:sp>
-      <p:sp>
-        <p:nvSpPr>
-          <p:cNvPr id="10" name="TextBox 9"/>
-          <p:cNvSpPr txBox="1"/>
-          <p:nvPr/>
-        </p:nvSpPr>
-        <p:spPr>
-          <a:xfrm>
-            <a:off x="2788920" y="1554480"/>
-            <a:ext cx="2112264" cy="457200"/>
-          </a:xfrm>
-          <a:prstGeom prst="rect">
-            <a:avLst/>
-          </a:prstGeom>
-          <a:noFill/>
-        </p:spPr>
-        <p:txBody>
-          <a:bodyPr wrap="square" anchor="t">
-            <a:spAutoFit/>
-          </a:bodyPr>
-          <a:lstStyle/>
-          <a:p>
-            <a:pPr algn="l">
-              <a:lnSpc>
-                <a:spcPct val="95000"/>
-              </a:lnSpc>
-            </a:pPr>
-            <a:r>
-              <a:rPr sz="1150" b="1" i="0">
-                <a:solidFill>
-                  <a:srgbClr val="38BDF8"/>
-                </a:solidFill>
-                <a:latin typeface="Calibri"/>
-              </a:rPr>
-              <a:t>Activités</a:t>
-            </a:r>
-          </a:p>
-          <a:p>
-            <a:pPr algn="l">
-              <a:lnSpc>
-                <a:spcPct val="95000"/>
-              </a:lnSpc>
-            </a:pPr>
-            <a:r>
-              <a:rPr sz="1150" b="1" i="0">
-                <a:solidFill>
-                  <a:srgbClr val="38BDF8"/>
-                </a:solidFill>
-                <a:latin typeface="Calibri"/>
-              </a:rPr>
-              <a:t>clés</a:t>
-            </a:r>
-          </a:p>
-        </p:txBody>
-      </p:sp>
-      <p:sp>
-        <p:nvSpPr>
-          <p:cNvPr id="11" name="TextBox 10"/>
-          <p:cNvSpPr txBox="1"/>
-          <p:nvPr/>
-        </p:nvSpPr>
-        <p:spPr>
-          <a:xfrm>
-            <a:off x="2788920" y="2075688"/>
-            <a:ext cx="2112264" cy="1805940"/>
-          </a:xfrm>
-          <a:prstGeom prst="rect">
-            <a:avLst/>
-          </a:prstGeom>
-          <a:noFill/>
-        </p:spPr>
-        <p:txBody>
-          <a:bodyPr wrap="square" anchor="t">
-            <a:spAutoFit/>
-          </a:bodyPr>
-          <a:lstStyle/>
-          <a:p>
-            <a:pPr algn="l">
-              <a:lnSpc>
-                <a:spcPct val="115000"/>
-              </a:lnSpc>
-            </a:pPr>
-            <a:r>
-              <a:rPr sz="950" b="0" i="0">
-                <a:solidFill>
-                  <a:srgbClr val="E2E8F0"/>
-                </a:solidFill>
-                <a:latin typeface="Calibri"/>
-              </a:rPr>
-              <a:t>Développement plateforme</a:t>
-            </a:r>
-          </a:p>
-          <a:p>
-            <a:pPr algn="l">
-              <a:lnSpc>
-                <a:spcPct val="115000"/>
-              </a:lnSpc>
-            </a:pPr>
-            <a:r>
-              <a:rPr sz="950" b="0" i="0">
-                <a:solidFill>
-                  <a:srgbClr val="E2E8F0"/>
-                </a:solidFill>
-                <a:latin typeface="Calibri"/>
-              </a:rPr>
-              <a:t>Déploiement terrain</a:t>
-            </a:r>
-          </a:p>
-          <a:p>
-            <a:pPr algn="l">
-              <a:lnSpc>
-                <a:spcPct val="115000"/>
-              </a:lnSpc>
-            </a:pPr>
-            <a:r>
-              <a:rPr sz="950" b="0" i="0">
-                <a:solidFill>
-                  <a:srgbClr val="E2E8F0"/>
-                </a:solidFill>
-                <a:latin typeface="Calibri"/>
-              </a:rPr>
-              <a:t>Support &amp; supervision</a:t>
-            </a:r>
-          </a:p>
-        </p:txBody>
-      </p:sp>
-      <p:sp>
-        <p:nvSpPr>
-          <p:cNvPr id="12" name="Rectangle 11"/>
-          <p:cNvSpPr/>
-          <p:nvPr/>
-        </p:nvSpPr>
-        <p:spPr>
-          <a:xfrm>
-            <a:off x="2715768" y="3954780"/>
-            <a:ext cx="2258568" cy="2446020"/>
-          </a:xfrm>
-          <a:prstGeom prst="rect">
-            <a:avLst/>
-          </a:prstGeom>
-          <a:solidFill>
-            <a:srgbClr val="1E293B"/>
-          </a:solidFill>
-          <a:ln w="9525">
-            <a:solidFill>
-              <a:srgbClr val="334155"/>
-            </a:solidFill>
-          </a:ln>
-          <a:effectLst/>
-        </p:spPr>
-        <p:style>
-          <a:lnRef idx="1">
-            <a:schemeClr val="accent1"/>
-          </a:lnRef>
-          <a:fillRef idx="3">
-            <a:schemeClr val="accent1"/>
-          </a:fillRef>
-          <a:effectRef idx="2">
-            <a:schemeClr val="accent1"/>
-          </a:effectRef>
-          <a:fontRef idx="minor">
-            <a:schemeClr val="lt1"/>
-          </a:fontRef>
-        </p:style>
-        <p:txBody>
-          <a:bodyPr rtlCol="0" anchor="ctr"/>
-          <a:lstStyle/>
-          <a:p>
-            <a:pPr algn="ctr"/>
-          </a:p>
-        </p:txBody>
-      </p:sp>
-      <p:sp>
-        <p:nvSpPr>
-          <p:cNvPr id="13" name="TextBox 12"/>
-          <p:cNvSpPr txBox="1"/>
-          <p:nvPr/>
-        </p:nvSpPr>
-        <p:spPr>
-          <a:xfrm>
-            <a:off x="2788920" y="4000500"/>
-            <a:ext cx="2112264" cy="457200"/>
-          </a:xfrm>
-          <a:prstGeom prst="rect">
-            <a:avLst/>
-          </a:prstGeom>
-          <a:noFill/>
-        </p:spPr>
-        <p:txBody>
-          <a:bodyPr wrap="square" anchor="t">
-            <a:spAutoFit/>
-          </a:bodyPr>
-          <a:lstStyle/>
-          <a:p>
-            <a:pPr algn="l">
-              <a:lnSpc>
-                <a:spcPct val="95000"/>
-              </a:lnSpc>
-            </a:pPr>
-            <a:r>
-              <a:rPr sz="1150" b="1" i="0">
-                <a:solidFill>
-                  <a:srgbClr val="38BDF8"/>
-                </a:solidFill>
-                <a:latin typeface="Calibri"/>
-              </a:rPr>
-              <a:t>Ressources</a:t>
-            </a:r>
-          </a:p>
-          <a:p>
-            <a:pPr algn="l">
-              <a:lnSpc>
-                <a:spcPct val="95000"/>
-              </a:lnSpc>
-            </a:pPr>
-            <a:r>
-              <a:rPr sz="1150" b="1" i="0">
-                <a:solidFill>
-                  <a:srgbClr val="38BDF8"/>
-                </a:solidFill>
-                <a:latin typeface="Calibri"/>
-              </a:rPr>
-              <a:t>clés</a:t>
-            </a:r>
-          </a:p>
-        </p:txBody>
-      </p:sp>
-      <p:sp>
-        <p:nvSpPr>
-          <p:cNvPr id="14" name="TextBox 13"/>
-          <p:cNvSpPr txBox="1"/>
-          <p:nvPr/>
-        </p:nvSpPr>
-        <p:spPr>
-          <a:xfrm>
-            <a:off x="2788920" y="4521708"/>
-            <a:ext cx="2112264" cy="1805940"/>
-          </a:xfrm>
-          <a:prstGeom prst="rect">
-            <a:avLst/>
-          </a:prstGeom>
-          <a:noFill/>
-        </p:spPr>
-        <p:txBody>
-          <a:bodyPr wrap="square" anchor="t">
-            <a:spAutoFit/>
-          </a:bodyPr>
-          <a:lstStyle/>
-          <a:p>
-            <a:pPr algn="l">
-              <a:lnSpc>
-                <a:spcPct val="115000"/>
-              </a:lnSpc>
-            </a:pPr>
-            <a:r>
-              <a:rPr sz="950" b="0" i="0">
-                <a:solidFill>
-                  <a:srgbClr val="E2E8F0"/>
-                </a:solidFill>
-                <a:latin typeface="Calibri"/>
-              </a:rPr>
-              <a:t>Plateforme logicielle</a:t>
-            </a:r>
-          </a:p>
-          <a:p>
-            <a:pPr algn="l">
-              <a:lnSpc>
-                <a:spcPct val="115000"/>
-              </a:lnSpc>
-            </a:pPr>
-            <a:r>
-              <a:rPr sz="950" b="0" i="0">
-                <a:solidFill>
-                  <a:srgbClr val="E2E8F0"/>
-                </a:solidFill>
-                <a:latin typeface="Calibri"/>
-              </a:rPr>
-              <a:t>Équipe technique</a:t>
-            </a:r>
-          </a:p>
-          <a:p>
-            <a:pPr algn="l">
-              <a:lnSpc>
-                <a:spcPct val="115000"/>
-              </a:lnSpc>
-            </a:pPr>
-            <a:r>
-              <a:rPr sz="950" b="0" i="0">
-                <a:solidFill>
-                  <a:srgbClr val="E2E8F0"/>
-                </a:solidFill>
-                <a:latin typeface="Calibri"/>
-              </a:rPr>
-              <a:t>Partenariats matériel</a:t>
-            </a:r>
-          </a:p>
-        </p:txBody>
-      </p:sp>
-      <p:sp>
-        <p:nvSpPr>
-          <p:cNvPr id="15" name="Rectangle 14"/>
-          <p:cNvSpPr/>
-          <p:nvPr/>
-        </p:nvSpPr>
-        <p:spPr>
-          <a:xfrm>
-            <a:off x="4974336" y="1508760"/>
-            <a:ext cx="2258568" cy="4892040"/>
-          </a:xfrm>
-          <a:prstGeom prst="rect">
-            <a:avLst/>
-          </a:prstGeom>
-          <a:solidFill>
-            <a:srgbClr val="1E293B"/>
-          </a:solidFill>
-          <a:ln w="9525">
-            <a:solidFill>
-              <a:srgbClr val="334155"/>
-            </a:solidFill>
-          </a:ln>
-          <a:effectLst/>
-        </p:spPr>
-        <p:style>
-          <a:lnRef idx="1">
-            <a:schemeClr val="accent1"/>
-          </a:lnRef>
-          <a:fillRef idx="3">
-            <a:schemeClr val="accent1"/>
-          </a:fillRef>
-          <a:effectRef idx="2">
-            <a:schemeClr val="accent1"/>
-          </a:effectRef>
-          <a:fontRef idx="minor">
-            <a:schemeClr val="lt1"/>
-          </a:fontRef>
-        </p:style>
-        <p:txBody>
-          <a:bodyPr rtlCol="0" anchor="ctr"/>
-          <a:lstStyle/>
-          <a:p>
-            <a:pPr algn="ctr"/>
-          </a:p>
-        </p:txBody>
-      </p:sp>
-      <p:sp>
-        <p:nvSpPr>
-          <p:cNvPr id="16" name="TextBox 15"/>
-          <p:cNvSpPr txBox="1"/>
-          <p:nvPr/>
-        </p:nvSpPr>
-        <p:spPr>
-          <a:xfrm>
-            <a:off x="5047488" y="1554480"/>
-            <a:ext cx="2112264" cy="457200"/>
-          </a:xfrm>
-          <a:prstGeom prst="rect">
-            <a:avLst/>
-          </a:prstGeom>
-          <a:noFill/>
-        </p:spPr>
-        <p:txBody>
-          <a:bodyPr wrap="square" anchor="t">
-            <a:spAutoFit/>
-          </a:bodyPr>
-          <a:lstStyle/>
-          <a:p>
-            <a:pPr algn="l">
-              <a:lnSpc>
-                <a:spcPct val="95000"/>
-              </a:lnSpc>
-            </a:pPr>
-            <a:r>
-              <a:rPr sz="1150" b="1" i="0">
-                <a:solidFill>
-                  <a:srgbClr val="38BDF8"/>
-                </a:solidFill>
-                <a:latin typeface="Calibri"/>
-              </a:rPr>
-              <a:t>Proposition</a:t>
-            </a:r>
-          </a:p>
-          <a:p>
-            <a:pPr algn="l">
-              <a:lnSpc>
-                <a:spcPct val="95000"/>
-              </a:lnSpc>
-            </a:pPr>
-            <a:r>
-              <a:rPr sz="1150" b="1" i="0">
-                <a:solidFill>
-                  <a:srgbClr val="38BDF8"/>
-                </a:solidFill>
-                <a:latin typeface="Calibri"/>
-              </a:rPr>
-              <a:t>de valeur</a:t>
-            </a:r>
-          </a:p>
-        </p:txBody>
-      </p:sp>
-      <p:sp>
-        <p:nvSpPr>
-          <p:cNvPr id="17" name="TextBox 16"/>
-          <p:cNvSpPr txBox="1"/>
-          <p:nvPr/>
-        </p:nvSpPr>
-        <p:spPr>
-          <a:xfrm>
-            <a:off x="5047488" y="2194560"/>
-            <a:ext cx="2112264" cy="4251960"/>
-          </a:xfrm>
-          <a:prstGeom prst="rect">
-            <a:avLst/>
-          </a:prstGeom>
-          <a:noFill/>
-        </p:spPr>
-        <p:txBody>
-          <a:bodyPr wrap="square" anchor="t">
-            <a:spAutoFit/>
-          </a:bodyPr>
-          <a:lstStyle/>
-          <a:p>
-            <a:pPr algn="l">
-              <a:lnSpc>
-                <a:spcPct val="115000"/>
-              </a:lnSpc>
-            </a:pPr>
-            <a:r>
-              <a:rPr sz="950" b="0" i="0">
-                <a:solidFill>
-                  <a:srgbClr val="E2E8F0"/>
-                </a:solidFill>
-                <a:latin typeface="Calibri"/>
-              </a:rPr>
-              <a:t>Économies d'énergie</a:t>
-            </a:r>
-          </a:p>
-          <a:p>
-            <a:pPr algn="l">
-              <a:lnSpc>
-                <a:spcPct val="115000"/>
-              </a:lnSpc>
-            </a:pPr>
-            <a:r>
-              <a:rPr sz="950" b="0" i="0">
-                <a:solidFill>
-                  <a:srgbClr val="E2E8F0"/>
-                </a:solidFill>
-                <a:latin typeface="Calibri"/>
-              </a:rPr>
-              <a:t>Détection proactive</a:t>
-            </a:r>
-          </a:p>
-          <a:p>
-            <a:pPr algn="l">
-              <a:lnSpc>
-                <a:spcPct val="115000"/>
-              </a:lnSpc>
-            </a:pPr>
-            <a:r>
-              <a:rPr sz="950" b="0" i="0">
-                <a:solidFill>
-                  <a:srgbClr val="E2E8F0"/>
-                </a:solidFill>
-                <a:latin typeface="Calibri"/>
-              </a:rPr>
-              <a:t>des pannes</a:t>
-            </a:r>
-          </a:p>
-          <a:p>
-            <a:pPr algn="l">
-              <a:lnSpc>
-                <a:spcPct val="115000"/>
-              </a:lnSpc>
-            </a:pPr>
-            <a:r>
-              <a:rPr sz="950" b="0" i="0">
-                <a:solidFill>
-                  <a:srgbClr val="E2E8F0"/>
-                </a:solidFill>
-                <a:latin typeface="Calibri"/>
-              </a:rPr>
-              <a:t>Traçabilité blockchain</a:t>
-            </a:r>
-          </a:p>
-          <a:p>
-            <a:pPr algn="l">
-              <a:lnSpc>
-                <a:spcPct val="115000"/>
-              </a:lnSpc>
-            </a:pPr>
-            <a:r>
-              <a:rPr sz="950" b="0" i="0">
-                <a:solidFill>
-                  <a:srgbClr val="E2E8F0"/>
-                </a:solidFill>
-                <a:latin typeface="Calibri"/>
-              </a:rPr>
-              <a:t>Dashboard simple</a:t>
-            </a:r>
-          </a:p>
-        </p:txBody>
-      </p:sp>
-      <p:sp>
-        <p:nvSpPr>
-          <p:cNvPr id="18" name="Rectangle 17"/>
-          <p:cNvSpPr/>
-          <p:nvPr/>
-        </p:nvSpPr>
-        <p:spPr>
-          <a:xfrm>
-            <a:off x="7232904" y="1508760"/>
-            <a:ext cx="2258568" cy="2446020"/>
-          </a:xfrm>
-          <a:prstGeom prst="rect">
-            <a:avLst/>
-          </a:prstGeom>
-          <a:solidFill>
-            <a:srgbClr val="1E293B"/>
-          </a:solidFill>
-          <a:ln w="9525">
-            <a:solidFill>
-              <a:srgbClr val="334155"/>
-            </a:solidFill>
-          </a:ln>
-          <a:effectLst/>
-        </p:spPr>
-        <p:style>
-          <a:lnRef idx="1">
-            <a:schemeClr val="accent1"/>
-          </a:lnRef>
-          <a:fillRef idx="3">
-            <a:schemeClr val="accent1"/>
-          </a:fillRef>
-          <a:effectRef idx="2">
-            <a:schemeClr val="accent1"/>
-          </a:effectRef>
-          <a:fontRef idx="minor">
-            <a:schemeClr val="lt1"/>
-          </a:fontRef>
-        </p:style>
-        <p:txBody>
-          <a:bodyPr rtlCol="0" anchor="ctr"/>
-          <a:lstStyle/>
-          <a:p>
-            <a:pPr algn="ctr"/>
-          </a:p>
-        </p:txBody>
-      </p:sp>
-      <p:sp>
-        <p:nvSpPr>
-          <p:cNvPr id="19" name="TextBox 18"/>
-          <p:cNvSpPr txBox="1"/>
-          <p:nvPr/>
-        </p:nvSpPr>
-        <p:spPr>
-          <a:xfrm>
-            <a:off x="7306056" y="1554480"/>
-            <a:ext cx="2112264" cy="457200"/>
-          </a:xfrm>
-          <a:prstGeom prst="rect">
-            <a:avLst/>
-          </a:prstGeom>
-          <a:noFill/>
-        </p:spPr>
-        <p:txBody>
-          <a:bodyPr wrap="square" anchor="t">
-            <a:spAutoFit/>
-          </a:bodyPr>
-          <a:lstStyle/>
-          <a:p>
-            <a:pPr algn="l">
-              <a:lnSpc>
-                <a:spcPct val="95000"/>
-              </a:lnSpc>
-            </a:pPr>
-            <a:r>
-              <a:rPr sz="1150" b="1" i="0">
-                <a:solidFill>
-                  <a:srgbClr val="38BDF8"/>
-                </a:solidFill>
-                <a:latin typeface="Calibri"/>
-              </a:rPr>
-              <a:t>Relations</a:t>
-            </a:r>
-          </a:p>
-          <a:p>
-            <a:pPr algn="l">
-              <a:lnSpc>
-                <a:spcPct val="95000"/>
-              </a:lnSpc>
-            </a:pPr>
-            <a:r>
-              <a:rPr sz="1150" b="1" i="0">
-                <a:solidFill>
-                  <a:srgbClr val="38BDF8"/>
-                </a:solidFill>
-                <a:latin typeface="Calibri"/>
-              </a:rPr>
-              <a:t>clients</a:t>
-            </a:r>
-          </a:p>
-        </p:txBody>
-      </p:sp>
-      <p:sp>
-        <p:nvSpPr>
-          <p:cNvPr id="20" name="TextBox 19"/>
-          <p:cNvSpPr txBox="1"/>
-          <p:nvPr/>
-        </p:nvSpPr>
-        <p:spPr>
-          <a:xfrm>
-            <a:off x="7306056" y="2075688"/>
-            <a:ext cx="2112264" cy="1805940"/>
-          </a:xfrm>
-          <a:prstGeom prst="rect">
-            <a:avLst/>
-          </a:prstGeom>
-          <a:noFill/>
-        </p:spPr>
-        <p:txBody>
-          <a:bodyPr wrap="square" anchor="t">
-            <a:spAutoFit/>
-          </a:bodyPr>
-          <a:lstStyle/>
-          <a:p>
-            <a:pPr algn="l">
-              <a:lnSpc>
-                <a:spcPct val="115000"/>
-              </a:lnSpc>
-            </a:pPr>
-            <a:r>
-              <a:rPr sz="950" b="0" i="0">
-                <a:solidFill>
-                  <a:srgbClr val="E2E8F0"/>
-                </a:solidFill>
-                <a:latin typeface="Calibri"/>
-              </a:rPr>
-              <a:t>Contrat long terme</a:t>
-            </a:r>
-          </a:p>
-          <a:p>
-            <a:pPr algn="l">
-              <a:lnSpc>
-                <a:spcPct val="115000"/>
-              </a:lnSpc>
-            </a:pPr>
-            <a:r>
-              <a:rPr sz="950" b="0" i="0">
-                <a:solidFill>
-                  <a:srgbClr val="E2E8F0"/>
-                </a:solidFill>
-                <a:latin typeface="Calibri"/>
-              </a:rPr>
-              <a:t>Support dédié</a:t>
-            </a:r>
-          </a:p>
-          <a:p>
-            <a:pPr algn="l">
-              <a:lnSpc>
-                <a:spcPct val="115000"/>
-              </a:lnSpc>
-            </a:pPr>
-            <a:r>
-              <a:rPr sz="950" b="0" i="0">
-                <a:solidFill>
-                  <a:srgbClr val="E2E8F0"/>
-                </a:solidFill>
-                <a:latin typeface="Calibri"/>
-              </a:rPr>
-              <a:t>Rapports automatisés</a:t>
-            </a:r>
-          </a:p>
-        </p:txBody>
-      </p:sp>
-      <p:sp>
-        <p:nvSpPr>
-          <p:cNvPr id="21" name="Rectangle 20"/>
-          <p:cNvSpPr/>
-          <p:nvPr/>
-        </p:nvSpPr>
-        <p:spPr>
-          <a:xfrm>
-            <a:off x="7232904" y="3954780"/>
-            <a:ext cx="2258568" cy="2446020"/>
-          </a:xfrm>
-          <a:prstGeom prst="rect">
-            <a:avLst/>
-          </a:prstGeom>
-          <a:solidFill>
-            <a:srgbClr val="1E293B"/>
-          </a:solidFill>
-          <a:ln w="9525">
-            <a:solidFill>
-              <a:srgbClr val="334155"/>
-            </a:solidFill>
-          </a:ln>
-          <a:effectLst/>
-        </p:spPr>
-        <p:style>
-          <a:lnRef idx="1">
-            <a:schemeClr val="accent1"/>
-          </a:lnRef>
-          <a:fillRef idx="3">
-            <a:schemeClr val="accent1"/>
-          </a:fillRef>
-          <a:effectRef idx="2">
-            <a:schemeClr val="accent1"/>
-          </a:effectRef>
-          <a:fontRef idx="minor">
-            <a:schemeClr val="lt1"/>
-          </a:fontRef>
-        </p:style>
-        <p:txBody>
-          <a:bodyPr rtlCol="0" anchor="ctr"/>
-          <a:lstStyle/>
-          <a:p>
-            <a:pPr algn="ctr"/>
-          </a:p>
-        </p:txBody>
-      </p:sp>
-      <p:sp>
-        <p:nvSpPr>
-          <p:cNvPr id="22" name="TextBox 21"/>
-          <p:cNvSpPr txBox="1"/>
-          <p:nvPr/>
-        </p:nvSpPr>
-        <p:spPr>
-          <a:xfrm>
-            <a:off x="7306056" y="4000500"/>
-            <a:ext cx="2112264" cy="457200"/>
-          </a:xfrm>
-          <a:prstGeom prst="rect">
-            <a:avLst/>
-          </a:prstGeom>
-          <a:noFill/>
-        </p:spPr>
-        <p:txBody>
-          <a:bodyPr wrap="square" anchor="t">
-            <a:spAutoFit/>
-          </a:bodyPr>
-          <a:lstStyle/>
-          <a:p>
-            <a:pPr algn="l">
-              <a:lnSpc>
-                <a:spcPct val="95000"/>
-              </a:lnSpc>
-            </a:pPr>
-            <a:r>
-              <a:rPr sz="1150" b="1" i="0">
-                <a:solidFill>
-                  <a:srgbClr val="38BDF8"/>
-                </a:solidFill>
-                <a:latin typeface="Calibri"/>
-              </a:rPr>
-              <a:t>Canaux</a:t>
-            </a:r>
-          </a:p>
-        </p:txBody>
-      </p:sp>
-      <p:sp>
-        <p:nvSpPr>
-          <p:cNvPr id="23" name="TextBox 22"/>
-          <p:cNvSpPr txBox="1"/>
-          <p:nvPr/>
-        </p:nvSpPr>
-        <p:spPr>
-          <a:xfrm>
-            <a:off x="7306056" y="4521708"/>
-            <a:ext cx="2112264" cy="1805940"/>
-          </a:xfrm>
-          <a:prstGeom prst="rect">
-            <a:avLst/>
-          </a:prstGeom>
-          <a:noFill/>
-        </p:spPr>
-        <p:txBody>
-          <a:bodyPr wrap="square" anchor="t">
-            <a:spAutoFit/>
-          </a:bodyPr>
-          <a:lstStyle/>
-          <a:p>
-            <a:pPr algn="l">
-              <a:lnSpc>
-                <a:spcPct val="115000"/>
-              </a:lnSpc>
-            </a:pPr>
-            <a:r>
-              <a:rPr sz="950" b="0" i="0">
-                <a:solidFill>
-                  <a:srgbClr val="E2E8F0"/>
-                </a:solidFill>
-                <a:latin typeface="Calibri"/>
-              </a:rPr>
-              <a:t>Appels d'offres</a:t>
-            </a:r>
-          </a:p>
-          <a:p>
-            <a:pPr algn="l">
-              <a:lnSpc>
-                <a:spcPct val="115000"/>
-              </a:lnSpc>
-            </a:pPr>
-            <a:r>
-              <a:rPr sz="950" b="0" i="0">
-                <a:solidFill>
-                  <a:srgbClr val="E2E8F0"/>
-                </a:solidFill>
-                <a:latin typeface="Calibri"/>
-              </a:rPr>
-              <a:t>Partenaires installateurs</a:t>
-            </a:r>
-          </a:p>
-          <a:p>
-            <a:pPr algn="l">
-              <a:lnSpc>
-                <a:spcPct val="115000"/>
-              </a:lnSpc>
-            </a:pPr>
-            <a:r>
-              <a:rPr sz="950" b="0" i="0">
-                <a:solidFill>
-                  <a:srgbClr val="E2E8F0"/>
-                </a:solidFill>
-                <a:latin typeface="Calibri"/>
-              </a:rPr>
-              <a:t>Démos pilotes</a:t>
-            </a:r>
-          </a:p>
-        </p:txBody>
-      </p:sp>
-      <p:sp>
-        <p:nvSpPr>
-          <p:cNvPr id="24" name="Rectangle 23"/>
-          <p:cNvSpPr/>
-          <p:nvPr/>
-        </p:nvSpPr>
-        <p:spPr>
-          <a:xfrm>
-            <a:off x="9491472" y="1508760"/>
-            <a:ext cx="2258568" cy="4892040"/>
-          </a:xfrm>
-          <a:prstGeom prst="rect">
-            <a:avLst/>
-          </a:prstGeom>
-          <a:solidFill>
-            <a:srgbClr val="1E293B"/>
-          </a:solidFill>
-          <a:ln w="9525">
-            <a:solidFill>
-              <a:srgbClr val="334155"/>
-            </a:solidFill>
-          </a:ln>
-          <a:effectLst/>
-        </p:spPr>
-        <p:style>
-          <a:lnRef idx="1">
-            <a:schemeClr val="accent1"/>
-          </a:lnRef>
-          <a:fillRef idx="3">
-            <a:schemeClr val="accent1"/>
-          </a:fillRef>
-          <a:effectRef idx="2">
-            <a:schemeClr val="accent1"/>
-          </a:effectRef>
-          <a:fontRef idx="minor">
-            <a:schemeClr val="lt1"/>
-          </a:fontRef>
-        </p:style>
-        <p:txBody>
-          <a:bodyPr rtlCol="0" anchor="ctr"/>
-          <a:lstStyle/>
-          <a:p>
-            <a:pPr algn="ctr"/>
-          </a:p>
-        </p:txBody>
-      </p:sp>
-      <p:sp>
-        <p:nvSpPr>
-          <p:cNvPr id="25" name="TextBox 24"/>
-          <p:cNvSpPr txBox="1"/>
-          <p:nvPr/>
-        </p:nvSpPr>
-        <p:spPr>
-          <a:xfrm>
-            <a:off x="9564624" y="1554480"/>
-            <a:ext cx="2112264" cy="457200"/>
-          </a:xfrm>
-          <a:prstGeom prst="rect">
-            <a:avLst/>
-          </a:prstGeom>
-          <a:noFill/>
-        </p:spPr>
-        <p:txBody>
-          <a:bodyPr wrap="square" anchor="t">
-            <a:spAutoFit/>
-          </a:bodyPr>
-          <a:lstStyle/>
-          <a:p>
-            <a:pPr algn="l">
-              <a:lnSpc>
-                <a:spcPct val="95000"/>
-              </a:lnSpc>
-            </a:pPr>
-            <a:r>
-              <a:rPr sz="1150" b="1" i="0">
-                <a:solidFill>
-                  <a:srgbClr val="38BDF8"/>
-                </a:solidFill>
-                <a:latin typeface="Calibri"/>
-              </a:rPr>
-              <a:t>Segments de</a:t>
-            </a:r>
-          </a:p>
-          <a:p>
-            <a:pPr algn="l">
-              <a:lnSpc>
-                <a:spcPct val="95000"/>
-              </a:lnSpc>
-            </a:pPr>
-            <a:r>
-              <a:rPr sz="1150" b="1" i="0">
-                <a:solidFill>
-                  <a:srgbClr val="38BDF8"/>
-                </a:solidFill>
-                <a:latin typeface="Calibri"/>
-              </a:rPr>
-              <a:t>clientèle</a:t>
-            </a:r>
-          </a:p>
-        </p:txBody>
-      </p:sp>
-      <p:sp>
-        <p:nvSpPr>
-          <p:cNvPr id="26" name="TextBox 25"/>
-          <p:cNvSpPr txBox="1"/>
-          <p:nvPr/>
-        </p:nvSpPr>
-        <p:spPr>
-          <a:xfrm>
-            <a:off x="9564624" y="2194560"/>
-            <a:ext cx="2112264" cy="4251960"/>
-          </a:xfrm>
-          <a:prstGeom prst="rect">
-            <a:avLst/>
-          </a:prstGeom>
-          <a:noFill/>
-        </p:spPr>
-        <p:txBody>
-          <a:bodyPr wrap="square" anchor="t">
-            <a:spAutoFit/>
-          </a:bodyPr>
-          <a:lstStyle/>
-          <a:p>
-            <a:pPr algn="l">
-              <a:lnSpc>
-                <a:spcPct val="115000"/>
-              </a:lnSpc>
-            </a:pPr>
-            <a:r>
-              <a:rPr sz="950" b="0" i="0">
-                <a:solidFill>
-                  <a:srgbClr val="E2E8F0"/>
-                </a:solidFill>
-                <a:latin typeface="Calibri"/>
-              </a:rPr>
-              <a:t>Municipalités</a:t>
-            </a:r>
-          </a:p>
-          <a:p>
-            <a:pPr algn="l">
-              <a:lnSpc>
-                <a:spcPct val="115000"/>
-              </a:lnSpc>
-            </a:pPr>
-            <a:r>
-              <a:rPr sz="950" b="0" i="0">
-                <a:solidFill>
-                  <a:srgbClr val="E2E8F0"/>
-                </a:solidFill>
-                <a:latin typeface="Calibri"/>
-              </a:rPr>
-              <a:t>et collectivités</a:t>
-            </a:r>
-          </a:p>
-          <a:p>
-            <a:pPr algn="l">
-              <a:lnSpc>
-                <a:spcPct val="115000"/>
-              </a:lnSpc>
-            </a:pPr>
-            <a:r>
-              <a:rPr sz="950" b="0" i="0">
-                <a:solidFill>
-                  <a:srgbClr val="E2E8F0"/>
-                </a:solidFill>
-                <a:latin typeface="Calibri"/>
-              </a:rPr>
-              <a:t>Délégataires</a:t>
-            </a:r>
-          </a:p>
-          <a:p>
-            <a:pPr algn="l">
-              <a:lnSpc>
-                <a:spcPct val="115000"/>
-              </a:lnSpc>
-            </a:pPr>
-            <a:r>
-              <a:rPr sz="950" b="0" i="0">
-                <a:solidFill>
-                  <a:srgbClr val="E2E8F0"/>
-                </a:solidFill>
-                <a:latin typeface="Calibri"/>
-              </a:rPr>
-              <a:t>d'infrastructures</a:t>
-            </a:r>
-          </a:p>
-          <a:p>
-            <a:pPr algn="l">
-              <a:lnSpc>
-                <a:spcPct val="115000"/>
-              </a:lnSpc>
-            </a:pPr>
-            <a:r>
-              <a:rPr sz="950" b="0" i="0">
-                <a:solidFill>
-                  <a:srgbClr val="E2E8F0"/>
-                </a:solidFill>
-                <a:latin typeface="Calibri"/>
-              </a:rPr>
-              <a:t>Campus / zones</a:t>
-            </a:r>
-          </a:p>
-          <a:p>
-            <a:pPr algn="l">
-              <a:lnSpc>
-                <a:spcPct val="115000"/>
-              </a:lnSpc>
-            </a:pPr>
-            <a:r>
-              <a:rPr sz="950" b="0" i="0">
-                <a:solidFill>
-                  <a:srgbClr val="E2E8F0"/>
-                </a:solidFill>
-                <a:latin typeface="Calibri"/>
-              </a:rPr>
-              <a:t>industrielles</a:t>
-            </a:r>
-          </a:p>
-        </p:txBody>
-      </p:sp>
-      <p:sp>
-        <p:nvSpPr>
-          <p:cNvPr id="27" name="Rectangle 26"/>
-          <p:cNvSpPr/>
-          <p:nvPr/>
-        </p:nvSpPr>
-        <p:spPr>
-          <a:xfrm>
-            <a:off x="457200" y="6492240"/>
-            <a:ext cx="5600700" cy="502920"/>
-          </a:xfrm>
-          <a:prstGeom prst="rect">
-            <a:avLst/>
-          </a:prstGeom>
-          <a:solidFill>
-            <a:srgbClr val="1E293B"/>
-          </a:solidFill>
-          <a:ln w="9525">
-            <a:solidFill>
-              <a:srgbClr val="334155"/>
-            </a:solidFill>
-          </a:ln>
-          <a:effectLst/>
-        </p:spPr>
-        <p:style>
-          <a:lnRef idx="1">
-            <a:schemeClr val="accent1"/>
-          </a:lnRef>
-          <a:fillRef idx="3">
-            <a:schemeClr val="accent1"/>
-          </a:fillRef>
-          <a:effectRef idx="2">
-            <a:schemeClr val="accent1"/>
-          </a:effectRef>
-          <a:fontRef idx="minor">
-            <a:schemeClr val="lt1"/>
-          </a:fontRef>
-        </p:style>
-        <p:txBody>
-          <a:bodyPr rtlCol="0" anchor="ctr"/>
-          <a:lstStyle/>
-          <a:p>
-            <a:pPr algn="ctr"/>
-          </a:p>
-        </p:txBody>
-      </p:sp>
-      <p:sp>
-        <p:nvSpPr>
-          <p:cNvPr id="28" name="TextBox 27"/>
-          <p:cNvSpPr txBox="1"/>
-          <p:nvPr/>
-        </p:nvSpPr>
-        <p:spPr>
-          <a:xfrm>
-            <a:off x="594360" y="6537960"/>
-            <a:ext cx="5372100" cy="411480"/>
-          </a:xfrm>
-          <a:prstGeom prst="rect">
-            <a:avLst/>
-          </a:prstGeom>
-          <a:noFill/>
-        </p:spPr>
-        <p:txBody>
-          <a:bodyPr wrap="square" anchor="ctr">
-            <a:spAutoFit/>
-          </a:bodyPr>
-          <a:lstStyle/>
-          <a:p>
-            <a:pPr algn="l">
+            <a:pPr algn="r">
               <a:lnSpc>
                 <a:spcPct val="100000"/>
               </a:lnSpc>
             </a:pPr>
             <a:r>
-              <a:rPr sz="1050" b="0" i="0">
-                <a:solidFill>
-                  <a:srgbClr val="E2E8F0"/>
-                </a:solidFill>
-                <a:latin typeface="Calibri"/>
-              </a:rPr>
-              <a:t>Structure de coûts : développement, hébergement, matériel IoT, équipe, marketing</a:t>
-            </a:r>
-          </a:p>
-        </p:txBody>
-      </p:sp>
-      <p:sp>
-        <p:nvSpPr>
-          <p:cNvPr id="29" name="Rectangle 28"/>
-          <p:cNvSpPr/>
-          <p:nvPr/>
-        </p:nvSpPr>
-        <p:spPr>
-          <a:xfrm>
-            <a:off x="6103620" y="6492240"/>
-            <a:ext cx="5600700" cy="502920"/>
-          </a:xfrm>
-          <a:prstGeom prst="rect">
-            <a:avLst/>
-          </a:prstGeom>
-          <a:solidFill>
-            <a:srgbClr val="1E293B"/>
-          </a:solidFill>
-          <a:ln w="9525">
-            <a:solidFill>
-              <a:srgbClr val="334155"/>
-            </a:solidFill>
-          </a:ln>
-          <a:effectLst/>
-        </p:spPr>
-        <p:style>
-          <a:lnRef idx="1">
-            <a:schemeClr val="accent1"/>
-          </a:lnRef>
-          <a:fillRef idx="3">
-            <a:schemeClr val="accent1"/>
-          </a:fillRef>
-          <a:effectRef idx="2">
-            <a:schemeClr val="accent1"/>
-          </a:effectRef>
-          <a:fontRef idx="minor">
-            <a:schemeClr val="lt1"/>
-          </a:fontRef>
-        </p:style>
-        <p:txBody>
-          <a:bodyPr rtlCol="0" anchor="ctr"/>
-          <a:lstStyle/>
-          <a:p>
-            <a:pPr algn="ctr"/>
-          </a:p>
-        </p:txBody>
-      </p:sp>
-      <p:sp>
-        <p:nvSpPr>
-          <p:cNvPr id="30" name="TextBox 29"/>
-          <p:cNvSpPr txBox="1"/>
-          <p:nvPr/>
-        </p:nvSpPr>
-        <p:spPr>
-          <a:xfrm>
-            <a:off x="6240780" y="6537960"/>
-            <a:ext cx="5372100" cy="411480"/>
-          </a:xfrm>
-          <a:prstGeom prst="rect">
-            <a:avLst/>
-          </a:prstGeom>
-          <a:noFill/>
-        </p:spPr>
-        <p:txBody>
-          <a:bodyPr wrap="square" anchor="ctr">
-            <a:spAutoFit/>
-          </a:bodyPr>
-          <a:lstStyle/>
-          <a:p>
-            <a:pPr algn="l">
-              <a:lnSpc>
-                <a:spcPct val="100000"/>
-              </a:lnSpc>
-            </a:pPr>
-            <a:r>
-              <a:rPr sz="1050" b="0" i="0">
-                <a:solidFill>
-                  <a:srgbClr val="E2E8F0"/>
-                </a:solidFill>
-                <a:latin typeface="Calibri"/>
-              </a:rPr>
-              <a:t>Sources de revenus : abonnement SaaS, vente/location matériel, installation, services</a:t>
-            </a:r>
-          </a:p>
-        </p:txBody>
-      </p:sp>
-      <p:sp>
-        <p:nvSpPr>
-          <p:cNvPr id="31" name="Rectangle 30"/>
-          <p:cNvSpPr/>
-          <p:nvPr/>
-        </p:nvSpPr>
-        <p:spPr>
-          <a:xfrm>
-            <a:off x="0" y="0"/>
-            <a:ext cx="12191695" cy="82296"/>
-          </a:xfrm>
-          <a:prstGeom prst="rect">
-            <a:avLst/>
-          </a:prstGeom>
-          <a:solidFill>
-            <a:srgbClr val="38BDF8"/>
-          </a:solidFill>
-          <a:ln>
-            <a:noFill/>
-          </a:ln>
-          <a:effectLst/>
-        </p:spPr>
-        <p:style>
-          <a:lnRef idx="1">
-            <a:schemeClr val="accent1"/>
-          </a:lnRef>
-          <a:fillRef idx="3">
-            <a:schemeClr val="accent1"/>
-          </a:fillRef>
-          <a:effectRef idx="2">
-            <a:schemeClr val="accent1"/>
-          </a:effectRef>
-          <a:fontRef idx="minor">
-            <a:schemeClr val="lt1"/>
-          </a:fontRef>
-        </p:style>
-        <p:txBody>
-          <a:bodyPr rtlCol="0" anchor="ctr"/>
-          <a:lstStyle/>
-          <a:p>
-            <a:pPr algn="ctr"/>
-          </a:p>
-        </p:txBody>
-      </p:sp>
-      <p:sp>
-        <p:nvSpPr>
-          <p:cNvPr id="32" name="TextBox 31"/>
-          <p:cNvSpPr txBox="1"/>
-          <p:nvPr/>
-        </p:nvSpPr>
-        <p:spPr>
-          <a:xfrm>
-            <a:off x="640080" y="6510528"/>
-            <a:ext cx="7315200" cy="274320"/>
-          </a:xfrm>
-          <a:prstGeom prst="rect">
-            <a:avLst/>
-          </a:prstGeom>
-          <a:noFill/>
-        </p:spPr>
-        <p:txBody>
-          <a:bodyPr wrap="square" anchor="t">
-            <a:spAutoFit/>
-          </a:bodyPr>
-          <a:lstStyle/>
-          <a:p>
-            <a:pPr algn="l">
-              <a:lnSpc>
-                <a:spcPct val="100000"/>
-              </a:lnSpc>
-            </a:pPr>
-            <a:r>
               <a:rPr sz="1000" b="0" i="0">
                 <a:solidFill>
-                  <a:srgbClr val="94A3B8"/>
-                </a:solidFill>
-                <a:latin typeface="Calibri"/>
-              </a:rPr>
-              <a:t>Business Model Canvas — Smart City Lighting Platform</a:t>
-            </a:r>
-          </a:p>
-        </p:txBody>
-      </p:sp>
-      <p:sp>
-        <p:nvSpPr>
-          <p:cNvPr id="33" name="TextBox 32"/>
-          <p:cNvSpPr txBox="1"/>
-          <p:nvPr/>
-        </p:nvSpPr>
-        <p:spPr>
-          <a:xfrm>
-            <a:off x="11247120" y="6510528"/>
-            <a:ext cx="548640" cy="274320"/>
-          </a:xfrm>
-          <a:prstGeom prst="rect">
-            <a:avLst/>
-          </a:prstGeom>
-          <a:noFill/>
-        </p:spPr>
-        <p:txBody>
-          <a:bodyPr wrap="square" anchor="t">
-            <a:spAutoFit/>
-          </a:bodyPr>
-          <a:lstStyle/>
-          <a:p>
-            <a:pPr algn="r">
-              <a:lnSpc>
-                <a:spcPct val="100000"/>
-              </a:lnSpc>
-            </a:pPr>
-            <a:r>
-              <a:rPr sz="1000" b="0" i="0">
-                <a:solidFill>
-                  <a:srgbClr val="94A3B8"/>
+                  <a:srgbClr val="64748B"/>
                 </a:solidFill>
                 <a:latin typeface="Calibri"/>
               </a:rPr>

</xml_diff>